<commit_message>
Update data collection dates
</commit_message>
<xml_diff>
--- a/Organisation/NaPiRE Flyer.pptx
+++ b/Organisation/NaPiRE Flyer.pptx
@@ -244,7 +244,7 @@
           <a:p>
             <a:fld id="{7CBC377A-BB38-ED4B-8E48-D215F9485276}" type="datetimeFigureOut">
               <a:rPr lang="en-GB" smtClean="0"/>
-              <a:t>11/12/2024</a:t>
+              <a:t>17/03/2025</a:t>
             </a:fld>
             <a:endParaRPr lang="en-GB"/>
           </a:p>
@@ -414,7 +414,7 @@
           <a:p>
             <a:fld id="{7CBC377A-BB38-ED4B-8E48-D215F9485276}" type="datetimeFigureOut">
               <a:rPr lang="en-GB" smtClean="0"/>
-              <a:t>11/12/2024</a:t>
+              <a:t>17/03/2025</a:t>
             </a:fld>
             <a:endParaRPr lang="en-GB"/>
           </a:p>
@@ -594,7 +594,7 @@
           <a:p>
             <a:fld id="{7CBC377A-BB38-ED4B-8E48-D215F9485276}" type="datetimeFigureOut">
               <a:rPr lang="en-GB" smtClean="0"/>
-              <a:t>11/12/2024</a:t>
+              <a:t>17/03/2025</a:t>
             </a:fld>
             <a:endParaRPr lang="en-GB"/>
           </a:p>
@@ -764,7 +764,7 @@
           <a:p>
             <a:fld id="{7CBC377A-BB38-ED4B-8E48-D215F9485276}" type="datetimeFigureOut">
               <a:rPr lang="en-GB" smtClean="0"/>
-              <a:t>11/12/2024</a:t>
+              <a:t>17/03/2025</a:t>
             </a:fld>
             <a:endParaRPr lang="en-GB"/>
           </a:p>
@@ -1010,7 +1010,7 @@
           <a:p>
             <a:fld id="{7CBC377A-BB38-ED4B-8E48-D215F9485276}" type="datetimeFigureOut">
               <a:rPr lang="en-GB" smtClean="0"/>
-              <a:t>11/12/2024</a:t>
+              <a:t>17/03/2025</a:t>
             </a:fld>
             <a:endParaRPr lang="en-GB"/>
           </a:p>
@@ -1242,7 +1242,7 @@
           <a:p>
             <a:fld id="{7CBC377A-BB38-ED4B-8E48-D215F9485276}" type="datetimeFigureOut">
               <a:rPr lang="en-GB" smtClean="0"/>
-              <a:t>11/12/2024</a:t>
+              <a:t>17/03/2025</a:t>
             </a:fld>
             <a:endParaRPr lang="en-GB"/>
           </a:p>
@@ -1609,7 +1609,7 @@
           <a:p>
             <a:fld id="{7CBC377A-BB38-ED4B-8E48-D215F9485276}" type="datetimeFigureOut">
               <a:rPr lang="en-GB" smtClean="0"/>
-              <a:t>11/12/2024</a:t>
+              <a:t>17/03/2025</a:t>
             </a:fld>
             <a:endParaRPr lang="en-GB"/>
           </a:p>
@@ -1727,7 +1727,7 @@
           <a:p>
             <a:fld id="{7CBC377A-BB38-ED4B-8E48-D215F9485276}" type="datetimeFigureOut">
               <a:rPr lang="en-GB" smtClean="0"/>
-              <a:t>11/12/2024</a:t>
+              <a:t>17/03/2025</a:t>
             </a:fld>
             <a:endParaRPr lang="en-GB"/>
           </a:p>
@@ -1822,7 +1822,7 @@
           <a:p>
             <a:fld id="{7CBC377A-BB38-ED4B-8E48-D215F9485276}" type="datetimeFigureOut">
               <a:rPr lang="en-GB" smtClean="0"/>
-              <a:t>11/12/2024</a:t>
+              <a:t>17/03/2025</a:t>
             </a:fld>
             <a:endParaRPr lang="en-GB"/>
           </a:p>
@@ -2099,7 +2099,7 @@
           <a:p>
             <a:fld id="{7CBC377A-BB38-ED4B-8E48-D215F9485276}" type="datetimeFigureOut">
               <a:rPr lang="en-GB" smtClean="0"/>
-              <a:t>11/12/2024</a:t>
+              <a:t>17/03/2025</a:t>
             </a:fld>
             <a:endParaRPr lang="en-GB"/>
           </a:p>
@@ -2356,7 +2356,7 @@
           <a:p>
             <a:fld id="{7CBC377A-BB38-ED4B-8E48-D215F9485276}" type="datetimeFigureOut">
               <a:rPr lang="en-GB" smtClean="0"/>
-              <a:t>11/12/2024</a:t>
+              <a:t>17/03/2025</a:t>
             </a:fld>
             <a:endParaRPr lang="en-GB"/>
           </a:p>
@@ -2569,7 +2569,7 @@
           <a:p>
             <a:fld id="{7CBC377A-BB38-ED4B-8E48-D215F9485276}" type="datetimeFigureOut">
               <a:rPr lang="en-GB" smtClean="0"/>
-              <a:t>11/12/2024</a:t>
+              <a:t>17/03/2025</a:t>
             </a:fld>
             <a:endParaRPr lang="en-GB"/>
           </a:p>
@@ -3681,7 +3681,7 @@
                 </a:solidFill>
                 <a:latin typeface="Helvetica" pitchFamily="2" charset="0"/>
               </a:rPr>
-              <a:t>March 31, 2025</a:t>
+              <a:t>April 30, 2025</a:t>
             </a:r>
           </a:p>
         </p:txBody>

</xml_diff>